<commit_message>
Added the frontend implementation
</commit_message>
<xml_diff>
--- a/Task 3/CEF440 Group15 Task3 Presentation.pptx
+++ b/Task 3/CEF440 Group15 Task3 Presentation.pptx
@@ -6083,13 +6083,13 @@
           <p:nvPr>
             <p:extLst>
               <p:ext uri="{D42A27DB-BD31-4B8C-83A1-F6EECF244321}">
-                <p14:modId xmlns:p14="http://schemas.microsoft.com/office/powerpoint/2010/main" val="3899548733"/>
+                <p14:modId xmlns:p14="http://schemas.microsoft.com/office/powerpoint/2010/main" val="528436610"/>
               </p:ext>
             </p:extLst>
           </p:nvPr>
         </p:nvGraphicFramePr>
         <p:xfrm>
-          <a:off x="0" y="531628"/>
+          <a:off x="7088" y="482009"/>
           <a:ext cx="9151088" cy="4611869"/>
         </p:xfrm>
         <a:graphic>
@@ -10530,7 +10530,7 @@
                 <a:ea typeface="Calibri" pitchFamily="34" charset="-122"/>
                 <a:cs typeface="Calibri" pitchFamily="34" charset="-120"/>
               </a:rPr>
-              <a:t>Core system built with React (frontend), Node.js/Express (backend), and MySQL — all widely-used, stable technologies.</a:t>
+              <a:t>Core system built with React (frontend), Node.js/Express (backend), and PostgreSQL — all widely-used, stable technologies.</a:t>
             </a:r>
             <a:endParaRPr lang="en-US" sz="1300" dirty="0"/>
           </a:p>

</xml_diff>